<commit_message>
Revise deck statistics to DCPC-validated figures (slides 5-6)
Slide 5: petrochemical imports now value-ranked with DCPC FY24-25 ₹ values —
PTA/PX ₹21,466 cr elevated (biggest cluster), PVC corrected to ₹9,224 cr,
colour = import dependence. Slide 6: chemical import bill $74bn->$70bn (DCPC
₹6.00 lakh cr), net deficit ~$26bn. Sources -> DCPC Statistics-at-a-Glance 2025.

Co-Authored-By: Claude Opus 4.8 <noreply@anthropic.com>
</commit_message>
<xml_diff>
--- a/docs/India_Fuel_to_Chemicals_PLI.pptx
+++ b/docs/India_Fuel_to_Chemicals_PLI.pptx
@@ -4658,7 +4658,7 @@
         <p:spPr>
           <a:xfrm>
             <a:off x="548640" y="1600200"/>
-            <a:ext cx="10972800" cy="457200"/>
+            <a:ext cx="11064240" cy="457200"/>
           </a:xfrm>
           <a:prstGeom prst="rect">
             <a:avLst/>
@@ -4682,7 +4682,7 @@
                 <a:ea typeface="Calibri" pitchFamily="34" charset="-122"/>
                 <a:cs typeface="Calibri" pitchFamily="34" charset="-120"/>
               </a:rPr>
-              <a:t>Made from the same petrol-range streams (naphtha → olefins, reformate → aromatics). Each with its 8-digit HSN code.</a:t>
+              <a:t>Top imports by value (DCPC FY2024-25). Made from the same petrol-range streams; colour = import dependence (red ~100% → teal lower).</a:t>
             </a:r>
             <a:endParaRPr lang="en-US" sz="1400" dirty="0"/>
           </a:p>
@@ -4748,7 +4748,7 @@
                 <a:ea typeface="Cambria" pitchFamily="34" charset="-122"/>
                 <a:cs typeface="Cambria" pitchFamily="34" charset="-120"/>
               </a:rPr>
-              <a:t>Styrene monomer</a:t>
+              <a:t>PTA + paraxylene → PET</a:t>
             </a:r>
             <a:endParaRPr lang="en-US" sz="1450" dirty="0"/>
           </a:p>
@@ -4787,7 +4787,7 @@
                 <a:ea typeface="Calibri" pitchFamily="34" charset="-122"/>
                 <a:cs typeface="Calibri" pitchFamily="34" charset="-120"/>
               </a:rPr>
-              <a:t>2902 50 00</a:t>
+              <a:t>2917 36 · 2902 43</a:t>
             </a:r>
             <a:endParaRPr lang="en-US" sz="1050" dirty="0"/>
           </a:p>
@@ -4810,7 +4810,7 @@
             </a:avLst>
           </a:prstGeom>
           <a:solidFill>
-            <a:srgbClr val="C4553E"/>
+            <a:srgbClr val="0F8B99"/>
           </a:solidFill>
           <a:ln/>
         </p:spPr>
@@ -4848,7 +4848,7 @@
                 <a:ea typeface="Calibri" pitchFamily="34" charset="-122"/>
                 <a:cs typeface="Calibri" pitchFamily="34" charset="-120"/>
               </a:rPr>
-              <a:t>~100%</a:t>
+              <a:t>₹21,466 cr</a:t>
             </a:r>
             <a:endParaRPr lang="en-US" sz="1100" dirty="0"/>
           </a:p>
@@ -4914,7 +4914,7 @@
                 <a:ea typeface="Cambria" pitchFamily="34" charset="-122"/>
                 <a:cs typeface="Cambria" pitchFamily="34" charset="-120"/>
               </a:rPr>
-              <a:t>Acrylonitrile</a:t>
+              <a:t>Polypropylene (inc. co-poly)</a:t>
             </a:r>
             <a:endParaRPr lang="en-US" sz="1450" dirty="0"/>
           </a:p>
@@ -4953,7 +4953,7 @@
                 <a:ea typeface="Calibri" pitchFamily="34" charset="-122"/>
                 <a:cs typeface="Calibri" pitchFamily="34" charset="-120"/>
               </a:rPr>
-              <a:t>2926 10 00</a:t>
+              <a:t>3902 10 00</a:t>
             </a:r>
             <a:endParaRPr lang="en-US" sz="1050" dirty="0"/>
           </a:p>
@@ -4976,7 +4976,7 @@
             </a:avLst>
           </a:prstGeom>
           <a:solidFill>
-            <a:srgbClr val="C4553E"/>
+            <a:srgbClr val="0F8B99"/>
           </a:solidFill>
           <a:ln/>
         </p:spPr>
@@ -5014,7 +5014,7 @@
                 <a:ea typeface="Calibri" pitchFamily="34" charset="-122"/>
                 <a:cs typeface="Calibri" pitchFamily="34" charset="-120"/>
               </a:rPr>
-              <a:t>~100%</a:t>
+              <a:t>₹15,627 cr</a:t>
             </a:r>
             <a:endParaRPr lang="en-US" sz="1100" dirty="0"/>
           </a:p>
@@ -5080,7 +5080,7 @@
                 <a:ea typeface="Cambria" pitchFamily="34" charset="-122"/>
                 <a:cs typeface="Cambria" pitchFamily="34" charset="-120"/>
               </a:rPr>
-              <a:t>Polycarbonate (BPA)</a:t>
+              <a:t>High-density polyethylene</a:t>
             </a:r>
             <a:endParaRPr lang="en-US" sz="1450" dirty="0"/>
           </a:p>
@@ -5119,7 +5119,7 @@
                 <a:ea typeface="Calibri" pitchFamily="34" charset="-122"/>
                 <a:cs typeface="Calibri" pitchFamily="34" charset="-120"/>
               </a:rPr>
-              <a:t>3907 40 00</a:t>
+              <a:t>3901 20 00</a:t>
             </a:r>
             <a:endParaRPr lang="en-US" sz="1050" dirty="0"/>
           </a:p>
@@ -5142,7 +5142,7 @@
             </a:avLst>
           </a:prstGeom>
           <a:solidFill>
-            <a:srgbClr val="C4553E"/>
+            <a:srgbClr val="0F8B99"/>
           </a:solidFill>
           <a:ln/>
         </p:spPr>
@@ -5180,7 +5180,7 @@
                 <a:ea typeface="Calibri" pitchFamily="34" charset="-122"/>
                 <a:cs typeface="Calibri" pitchFamily="34" charset="-120"/>
               </a:rPr>
-              <a:t>~90-100%</a:t>
+              <a:t>₹12,187 cr</a:t>
             </a:r>
             <a:endParaRPr lang="en-US" sz="1100" dirty="0"/>
           </a:p>
@@ -5246,7 +5246,7 @@
                 <a:ea typeface="Cambria" pitchFamily="34" charset="-122"/>
                 <a:cs typeface="Cambria" pitchFamily="34" charset="-120"/>
               </a:rPr>
-              <a:t>MDI / TDI (isocyanates)</a:t>
+              <a:t>Styrene monomer</a:t>
             </a:r>
             <a:endParaRPr lang="en-US" sz="1450" dirty="0"/>
           </a:p>
@@ -5285,7 +5285,7 @@
                 <a:ea typeface="Calibri" pitchFamily="34" charset="-122"/>
                 <a:cs typeface="Calibri" pitchFamily="34" charset="-120"/>
               </a:rPr>
-              <a:t>2929 10 20 / 10</a:t>
+              <a:t>2902 50 00</a:t>
             </a:r>
             <a:endParaRPr lang="en-US" sz="1050" dirty="0"/>
           </a:p>
@@ -5308,7 +5308,7 @@
             </a:avLst>
           </a:prstGeom>
           <a:solidFill>
-            <a:srgbClr val="D6A143"/>
+            <a:srgbClr val="C4553E"/>
           </a:solidFill>
           <a:ln/>
         </p:spPr>
@@ -5346,7 +5346,7 @@
                 <a:ea typeface="Calibri" pitchFamily="34" charset="-122"/>
                 <a:cs typeface="Calibri" pitchFamily="34" charset="-120"/>
               </a:rPr>
-              <a:t>~85-90%</a:t>
+              <a:t>₹11,105 cr</a:t>
             </a:r>
             <a:endParaRPr lang="en-US" sz="1100" dirty="0"/>
           </a:p>
@@ -5412,7 +5412,7 @@
                 <a:ea typeface="Cambria" pitchFamily="34" charset="-122"/>
                 <a:cs typeface="Cambria" pitchFamily="34" charset="-120"/>
               </a:rPr>
-              <a:t>PVC resin</a:t>
+              <a:t>PVC + VCM + EDC chain</a:t>
             </a:r>
             <a:endParaRPr lang="en-US" sz="1450" dirty="0"/>
           </a:p>
@@ -5451,7 +5451,7 @@
                 <a:ea typeface="Calibri" pitchFamily="34" charset="-122"/>
                 <a:cs typeface="Calibri" pitchFamily="34" charset="-120"/>
               </a:rPr>
-              <a:t>3904 10 10</a:t>
+              <a:t>3904 · 2903 21</a:t>
             </a:r>
             <a:endParaRPr lang="en-US" sz="1050" dirty="0"/>
           </a:p>
@@ -5512,7 +5512,7 @@
                 <a:ea typeface="Calibri" pitchFamily="34" charset="-122"/>
                 <a:cs typeface="Calibri" pitchFamily="34" charset="-120"/>
               </a:rPr>
-              <a:t>~55-75%</a:t>
+              <a:t>₹9,224 cr</a:t>
             </a:r>
             <a:endParaRPr lang="en-US" sz="1100" dirty="0"/>
           </a:p>
@@ -5578,7 +5578,7 @@
                 <a:ea typeface="Cambria" pitchFamily="34" charset="-122"/>
                 <a:cs typeface="Cambria" pitchFamily="34" charset="-120"/>
               </a:rPr>
-              <a:t>Polyethylene</a:t>
+              <a:t>Butadiene rubber (SBR+PBR)</a:t>
             </a:r>
             <a:endParaRPr lang="en-US" sz="1450" dirty="0"/>
           </a:p>
@@ -5617,7 +5617,7 @@
                 <a:ea typeface="Calibri" pitchFamily="34" charset="-122"/>
                 <a:cs typeface="Calibri" pitchFamily="34" charset="-120"/>
               </a:rPr>
-              <a:t>3901 10/20/40</a:t>
+              <a:t>4002 20 00</a:t>
             </a:r>
             <a:endParaRPr lang="en-US" sz="1050" dirty="0"/>
           </a:p>
@@ -5640,7 +5640,7 @@
             </a:avLst>
           </a:prstGeom>
           <a:solidFill>
-            <a:srgbClr val="0F8B99"/>
+            <a:srgbClr val="D6A143"/>
           </a:solidFill>
           <a:ln/>
         </p:spPr>
@@ -5678,7 +5678,7 @@
                 <a:ea typeface="Calibri" pitchFamily="34" charset="-122"/>
                 <a:cs typeface="Calibri" pitchFamily="34" charset="-120"/>
               </a:rPr>
-              <a:t>~25-40%</a:t>
+              <a:t>₹6,077 cr</a:t>
             </a:r>
             <a:endParaRPr lang="en-US" sz="1100" dirty="0"/>
           </a:p>
@@ -5744,7 +5744,7 @@
                 <a:ea typeface="Cambria" pitchFamily="34" charset="-122"/>
                 <a:cs typeface="Cambria" pitchFamily="34" charset="-120"/>
               </a:rPr>
-              <a:t>Polypropylene</a:t>
+              <a:t>Polycarbonate (BPA)</a:t>
             </a:r>
             <a:endParaRPr lang="en-US" sz="1450" dirty="0"/>
           </a:p>
@@ -5783,7 +5783,7 @@
                 <a:ea typeface="Calibri" pitchFamily="34" charset="-122"/>
                 <a:cs typeface="Calibri" pitchFamily="34" charset="-120"/>
               </a:rPr>
-              <a:t>3902 10 00</a:t>
+              <a:t>3907 40 00</a:t>
             </a:r>
             <a:endParaRPr lang="en-US" sz="1050" dirty="0"/>
           </a:p>
@@ -5806,7 +5806,7 @@
             </a:avLst>
           </a:prstGeom>
           <a:solidFill>
-            <a:srgbClr val="0F8B99"/>
+            <a:srgbClr val="C4553E"/>
           </a:solidFill>
           <a:ln/>
         </p:spPr>
@@ -5844,7 +5844,7 @@
                 <a:ea typeface="Calibri" pitchFamily="34" charset="-122"/>
                 <a:cs typeface="Calibri" pitchFamily="34" charset="-120"/>
               </a:rPr>
-              <a:t>~20-25%</a:t>
+              <a:t>₹5,545 cr</a:t>
             </a:r>
             <a:endParaRPr lang="en-US" sz="1100" dirty="0"/>
           </a:p>
@@ -5910,7 +5910,7 @@
                 <a:ea typeface="Cambria" pitchFamily="34" charset="-122"/>
                 <a:cs typeface="Cambria" pitchFamily="34" charset="-120"/>
               </a:rPr>
-              <a:t>MEG · epoxy · nylon · PTA</a:t>
+              <a:t>MEG · MDI · ACN · phenol</a:t>
             </a:r>
             <a:endParaRPr lang="en-US" sz="1450" dirty="0"/>
           </a:p>
@@ -5949,7 +5949,7 @@
                 <a:ea typeface="Calibri" pitchFamily="34" charset="-122"/>
                 <a:cs typeface="Calibri" pitchFamily="34" charset="-120"/>
               </a:rPr>
-              <a:t>2905/3907/3908</a:t>
+              <a:t>2905 · 2929 · 2926</a:t>
             </a:r>
             <a:endParaRPr lang="en-US" sz="1050" dirty="0"/>
           </a:p>
@@ -5972,7 +5972,7 @@
             </a:avLst>
           </a:prstGeom>
           <a:solidFill>
-            <a:srgbClr val="2E9E6B"/>
+            <a:srgbClr val="D6A143"/>
           </a:solidFill>
           <a:ln/>
         </p:spPr>
@@ -6010,7 +6010,7 @@
                 <a:ea typeface="Calibri" pitchFamily="34" charset="-122"/>
                 <a:cs typeface="Calibri" pitchFamily="34" charset="-120"/>
               </a:rPr>
-              <a:t>high / partial</a:t>
+              <a:t>₹5–15k cr</a:t>
             </a:r>
             <a:endParaRPr lang="en-US" sz="1100" dirty="0"/>
           </a:p>
@@ -6049,7 +6049,7 @@
                 <a:ea typeface="Calibri" pitchFamily="34" charset="-122"/>
                 <a:cs typeface="Calibri" pitchFamily="34" charset="-120"/>
               </a:rPr>
-              <a:t>Import dependence, colour-coded. Ethanol-freed feedstock alone could substitute 35–53% of these. Source: ICIS flowchart · MoC · DGCIS.</a:t>
+              <a:t>₹ = DCPC Statistics-at-a-Glance 2025 import value (FY24-25). Ethanol-freed feedstock alone could substitute 35–53%. Chain: ICIS flowchart.</a:t>
             </a:r>
             <a:endParaRPr lang="en-US" sz="900" dirty="0"/>
           </a:p>
@@ -6350,7 +6350,7 @@
                 <a:ea typeface="Cambria" pitchFamily="34" charset="-122"/>
                 <a:cs typeface="Cambria" pitchFamily="34" charset="-120"/>
               </a:rPr>
-              <a:t>$74 bn</a:t>
+              <a:t>$70 bn</a:t>
             </a:r>
             <a:endParaRPr lang="en-US" sz="2900" dirty="0"/>
           </a:p>
@@ -6392,7 +6392,7 @@
                 <a:ea typeface="Calibri" pitchFamily="34" charset="-122"/>
                 <a:cs typeface="Calibri" pitchFamily="34" charset="-120"/>
               </a:rPr>
-              <a:t>India's chemical import bill</a:t>
+              <a:t>chemical import bill (DCPC)</a:t>
             </a:r>
             <a:endParaRPr lang="en-US" sz="1150" dirty="0"/>
           </a:p>
@@ -6781,7 +6781,7 @@
                 <a:ea typeface="Calibri" pitchFamily="34" charset="-122"/>
                 <a:cs typeface="Calibri" pitchFamily="34" charset="-120"/>
               </a:rPr>
-              <a:t>Sources: PIB (PLI programme) · MoC Statistics-at-a-Glance · DGCIS.</a:t>
+              <a:t>Sources: PIB (PLI programme) · DCPC Statistics-at-a-Glance 2025 (chem import ₹6.00 lakh cr; net deficit ~$26 bn) · DGCIS.</a:t>
             </a:r>
             <a:endParaRPr lang="en-US" sz="900" dirty="0"/>
           </a:p>

</xml_diff>